<commit_message>
Fix SSC presentation title
</commit_message>
<xml_diff>
--- a/presentation/pnp_pinn_ssc_2026_presentation.pptx
+++ b/presentation/pnp_pinn_ssc_2026_presentation.pptx
@@ -2176,33 +2176,20 @@
                   <a:srgbClr val="151515"/>
                 </a:solidFill>
                 <a:latin typeface="Arial"/>
-                <a:ea typeface="Arial"/>
-                <a:cs typeface="Arial"/>
               </a:rPr>
-              <a:t>Current-Based Bayesian Inference</a:t>
+              <a:t>A Parameterized PINN Solution to the</a:t>
             </a:r>
           </a:p>
           <a:p xmlns:a="http://schemas.openxmlformats.org/drawingml/2006/main">
-            <a:pPr algn="l">
-              <a:defRPr sz="2550" b="1">
-                <a:solidFill>
-                  <a:srgbClr val="151515"/>
-                </a:solidFill>
-                <a:latin typeface="Arial"/>
-                <a:ea typeface="Arial"/>
-                <a:cs typeface="Arial"/>
-              </a:defRPr>
-            </a:pPr>
+            <a:pPr algn="l"/>
             <a:r>
               <a:rPr sz="2550" b="1">
                 <a:solidFill>
                   <a:srgbClr val="151515"/>
                 </a:solidFill>
                 <a:latin typeface="Arial"/>
-                <a:ea typeface="Arial"/>
-                <a:cs typeface="Arial"/>
               </a:rPr>
-              <a:t>for a 1D Poisson-Nernst-Planck System</a:t>
+              <a:t>Poisson Nernst Planck Model</a:t>
             </a:r>
           </a:p>
         </p:txBody>

</xml_diff>